<commit_message>
chore: rename project references from DocOct to PaperAI
</commit_message>
<xml_diff>
--- a/DocOct-Pitch.pptx
+++ b/DocOct-Pitch.pptx
@@ -1599,7 +1599,7 @@
                 <a:ea typeface="Georgia" pitchFamily="34" charset="-122"/>
                 <a:cs typeface="Georgia" pitchFamily="34" charset="-120"/>
               </a:rPr>
-              <a:t>DocOct</a:t>
+              <a:t>PaperAI</a:t>
             </a:r>
             <a:endParaRPr lang="en-US" sz="5200" dirty="0"/>
           </a:p>
@@ -1777,7 +1777,7 @@
                 <a:ea typeface="Calibri" pitchFamily="34" charset="-122"/>
                 <a:cs typeface="Calibri" pitchFamily="34" charset="-120"/>
               </a:rPr>
-              <a:t>sanir321-doc-oct.up.railway.app</a:t>
+              <a:t>sanir321-paper-ai.up.railway.app</a:t>
             </a:r>
             <a:endParaRPr lang="en-US" sz="1000" dirty="0"/>
           </a:p>
@@ -7326,7 +7326,7 @@
                 <a:ea typeface="Calibri" pitchFamily="34" charset="-122"/>
                 <a:cs typeface="Calibri" pitchFamily="34" charset="-120"/>
               </a:rPr>
-              <a:t>Join researchers and professionals already using DocOct</a:t>
+              <a:t>Join researchers and professionals already using PaperAI</a:t>
             </a:r>
             <a:endParaRPr lang="en-US" sz="1600" dirty="0"/>
           </a:p>
@@ -7392,7 +7392,7 @@
                 <a:ea typeface="Calibri" pitchFamily="34" charset="-122"/>
                 <a:cs typeface="Calibri" pitchFamily="34" charset="-120"/>
               </a:rPr>
-              <a:t>Launch DocOct  →</a:t>
+              <a:t>Launch PaperAI  →</a:t>
             </a:r>
             <a:endParaRPr lang="en-US" sz="1800" dirty="0"/>
           </a:p>
@@ -7431,7 +7431,7 @@
                 <a:ea typeface="Calibri" pitchFamily="34" charset="-122"/>
                 <a:cs typeface="Calibri" pitchFamily="34" charset="-120"/>
               </a:rPr>
-              <a:t>sanir321-doc-oct.up.railway.app</a:t>
+              <a:t>sanir321-paper-ai.up.railway.app</a:t>
             </a:r>
             <a:endParaRPr lang="en-US" sz="1300" dirty="0"/>
           </a:p>

</xml_diff>